<commit_message>
Slides updated to census-anchored CoI, age disaggregation, split figures, employment-first recommendations
</commit_message>
<xml_diff>
--- a/reports/nepal_slides_short.pptx
+++ b/reports/nepal_slides_short.pptx
@@ -11,6 +11,10 @@
     <p:sldId id="259" r:id="rId5"/>
     <p:sldId id="260" r:id="rId6"/>
     <p:sldId id="261" r:id="rId7"/>
+    <p:sldId id="262" r:id="rId8"/>
+    <p:sldId id="263" r:id="rId9"/>
+    <p:sldId id="264" r:id="rId10"/>
+    <p:sldId id="265" r:id="rId11"/>
   </p:sldIdLst>
   <p:sldSz cx="9144000" cy="5143500" type="screen16x9"/>
   <p:notesSz cx="6858000" cy="9144000"/>
@@ -3152,11 +3156,6 @@
             <a:br/>
             <a:r>
               <a:rPr/>
-              <a:t>Hernando Grueso, PhD</a:t>
-            </a:r>
-            <a:br/>
-            <a:r>
-              <a:rPr/>
               <a:t>UNICEF</a:t>
             </a:r>
           </a:p>
@@ -3187,6 +3186,28 @@
           </a:p>
         </p:txBody>
       </p:sp>
+    </p:spTree>
+  </p:cSld>
+</p:sld>
+</file>
+
+<file path=ppt/slides/slide10.xml><?xml version="1.0" encoding="utf-8"?>
+<p:sld xmlns:a="http://schemas.openxmlformats.org/drawingml/2006/main" xmlns:r="http://schemas.openxmlformats.org/officeDocument/2006/relationships" xmlns:p="http://schemas.openxmlformats.org/presentationml/2006/main">
+  <p:cSld>
+    <p:spTree>
+      <p:nvGrpSpPr>
+        <p:cNvPr id="1" name=""/>
+        <p:cNvGrpSpPr/>
+        <p:nvPr/>
+      </p:nvGrpSpPr>
+      <p:grpSpPr>
+        <a:xfrm>
+          <a:off x="0" y="0"/>
+          <a:ext cx="0" cy="0"/>
+          <a:chOff x="0" y="0"/>
+          <a:chExt cx="0" cy="0"/>
+        </a:xfrm>
+      </p:grpSpPr>
     </p:spTree>
   </p:cSld>
 </p:sld>
@@ -3404,8 +3425,8 @@
         </p:blipFill>
         <p:spPr bwMode="auto">
           <a:xfrm>
-            <a:off x="457200" y="1879600"/>
-            <a:ext cx="4038600" cy="2019300"/>
+            <a:off x="457200" y="1917700"/>
+            <a:ext cx="4038600" cy="1955800"/>
           </a:xfrm>
           <a:prstGeom prst="rect">
             <a:avLst/>
@@ -3460,7 +3481,7 @@
             </a:pPr>
             <a:r>
               <a:rPr/>
-              <a:t>The Recommendation: Invest at 16–18, Not 19+</a:t>
+              <a:t>The Recommendation: Four Priority Areas</a:t>
             </a:r>
           </a:p>
         </p:txBody>
@@ -3487,6 +3508,288 @@
           <a:chExt cx="0" cy="0"/>
         </a:xfrm>
       </p:grpSpPr>
+      <p:sp>
+        <p:nvSpPr>
+          <p:cNvPr id="2" name="Title 1"/>
+          <p:cNvSpPr>
+            <a:spLocks noGrp="1"/>
+          </p:cNvSpPr>
+          <p:nvPr>
+            <p:ph type="title"/>
+          </p:nvPr>
+        </p:nvSpPr>
+        <p:spPr/>
+        <p:txBody>
+          <a:bodyPr/>
+          <a:lstStyle/>
+          <a:p>
+            <a:pPr lvl="0" indent="0" marL="0">
+              <a:buNone/>
+            </a:pPr>
+            <a:r>
+              <a:rPr/>
+              <a:t>The Same Lens Elsewhere — Bolivia: a Different Diagnosis</a:t>
+            </a:r>
+          </a:p>
+        </p:txBody>
+      </p:sp>
+      <p:pic>
+        <p:nvPicPr>
+          <p:cNvPr descr="../outputs/figures/bolivia_f7_violence_2panel_en.png" id="0" name="Picture 1"/>
+          <p:cNvPicPr>
+            <a:picLocks noGrp="1" noChangeAspect="1"/>
+          </p:cNvPicPr>
+          <p:nvPr/>
+        </p:nvPicPr>
+        <p:blipFill>
+          <a:blip r:embed="rId2"/>
+          <a:stretch>
+            <a:fillRect/>
+          </a:stretch>
+        </p:blipFill>
+        <p:spPr bwMode="auto">
+          <a:xfrm>
+            <a:off x="508000" y="1193800"/>
+            <a:ext cx="8115300" cy="3390900"/>
+          </a:xfrm>
+          <a:prstGeom prst="rect">
+            <a:avLst/>
+          </a:prstGeom>
+          <a:noFill/>
+          <a:ln w="9525">
+            <a:noFill/>
+            <a:headEnd/>
+            <a:tailEnd/>
+          </a:ln>
+        </p:spPr>
+      </p:pic>
+    </p:spTree>
+  </p:cSld>
+</p:sld>
+</file>
+
+<file path=ppt/slides/slide7.xml><?xml version="1.0" encoding="utf-8"?>
+<p:sld xmlns:a="http://schemas.openxmlformats.org/drawingml/2006/main" xmlns:r="http://schemas.openxmlformats.org/officeDocument/2006/relationships" xmlns:p="http://schemas.openxmlformats.org/presentationml/2006/main">
+  <p:cSld>
+    <p:spTree>
+      <p:nvGrpSpPr>
+        <p:cNvPr id="1" name=""/>
+        <p:cNvGrpSpPr/>
+        <p:nvPr/>
+      </p:nvGrpSpPr>
+      <p:grpSpPr>
+        <a:xfrm>
+          <a:off x="0" y="0"/>
+          <a:ext cx="0" cy="0"/>
+          <a:chOff x="0" y="0"/>
+          <a:chExt cx="0" cy="0"/>
+        </a:xfrm>
+      </p:grpSpPr>
+      <p:sp>
+        <p:nvSpPr>
+          <p:cNvPr id="3" name="Content Placeholder 2"/>
+          <p:cNvSpPr>
+            <a:spLocks noGrp="1"/>
+          </p:cNvSpPr>
+          <p:nvPr>
+            <p:ph idx="1"/>
+          </p:nvPr>
+        </p:nvSpPr>
+        <p:spPr/>
+        <p:txBody>
+          <a:bodyPr/>
+          <a:lstStyle/>
+          <a:p>
+            <a:pPr lvl="0" indent="0" marL="0">
+              <a:buNone/>
+            </a:pPr>
+            <a:r>
+              <a:rPr/>
+              <a:t>In Bolivia (Aula Conectada investment case) girls are </a:t>
+            </a:r>
+            <a:r>
+              <a:rPr b="1"/>
+              <a:t>already in school</a:t>
+            </a:r>
+            <a:r>
+              <a:rPr/>
+              <a:t> (~92% enrolment ages 10–19, no gender gap in access); the binding constraints are </a:t>
+            </a:r>
+            <a:r>
+              <a:rPr b="1"/>
+              <a:t>learning quality, retention past 15, and the home environment</a:t>
+            </a:r>
+            <a:r>
+              <a:rPr/>
+              <a:t>. Violent discipline is concentrated in rural (52% vs 32% urban) and indigenous (46% vs 35%) homes and is associated with ~2 fewer years of schooling; </a:t>
+            </a:r>
+            <a:r>
+              <a:rPr b="1"/>
+              <a:t>early pregnancy</a:t>
+            </a:r>
+            <a:r>
+              <a:rPr/>
+              <a:t> is the strongest schooling correlate (−2.9 years). Contrast with Nepal: Nepal’s gap is the school-to-work transition; Bolivia’s is learning and retention — the same diagnostic lens, a different policy answer. Source: EDSA 2023 (INE Bolivia), survey-weighted.</a:t>
+            </a:r>
+          </a:p>
+        </p:txBody>
+      </p:sp>
+    </p:spTree>
+  </p:cSld>
+</p:sld>
+</file>
+
+<file path=ppt/slides/slide8.xml><?xml version="1.0" encoding="utf-8"?>
+<p:sld xmlns:a="http://schemas.openxmlformats.org/drawingml/2006/main" xmlns:r="http://schemas.openxmlformats.org/officeDocument/2006/relationships" xmlns:p="http://schemas.openxmlformats.org/presentationml/2006/main">
+  <p:cSld>
+    <p:spTree>
+      <p:nvGrpSpPr>
+        <p:cNvPr id="1" name=""/>
+        <p:cNvGrpSpPr/>
+        <p:nvPr/>
+      </p:nvGrpSpPr>
+      <p:grpSpPr>
+        <a:xfrm>
+          <a:off x="0" y="0"/>
+          <a:ext cx="0" cy="0"/>
+          <a:chOff x="0" y="0"/>
+          <a:chExt cx="0" cy="0"/>
+        </a:xfrm>
+      </p:grpSpPr>
+      <p:sp>
+        <p:nvSpPr>
+          <p:cNvPr id="2" name="Title 1"/>
+          <p:cNvSpPr>
+            <a:spLocks noGrp="1"/>
+          </p:cNvSpPr>
+          <p:nvPr>
+            <p:ph type="title"/>
+          </p:nvPr>
+        </p:nvSpPr>
+        <p:spPr/>
+        <p:txBody>
+          <a:bodyPr/>
+          <a:lstStyle/>
+          <a:p>
+            <a:pPr lvl="0" indent="0" marL="0">
+              <a:buNone/>
+            </a:pPr>
+            <a:r>
+              <a:rPr/>
+              <a:t>Bolivia: Evidence-Matched Theory of Change — BCR ≈ 4–6</a:t>
+            </a:r>
+          </a:p>
+        </p:txBody>
+      </p:sp>
+      <p:pic>
+        <p:nvPicPr>
+          <p:cNvPr descr="../outputs/figures/bolivia_f_toc_en.png" id="0" name="Picture 1"/>
+          <p:cNvPicPr>
+            <a:picLocks noGrp="1" noChangeAspect="1"/>
+          </p:cNvPicPr>
+          <p:nvPr/>
+        </p:nvPicPr>
+        <p:blipFill>
+          <a:blip r:embed="rId2"/>
+          <a:stretch>
+            <a:fillRect/>
+          </a:stretch>
+        </p:blipFill>
+        <p:spPr bwMode="auto">
+          <a:xfrm>
+            <a:off x="673100" y="1193800"/>
+            <a:ext cx="7797800" cy="3390900"/>
+          </a:xfrm>
+          <a:prstGeom prst="rect">
+            <a:avLst/>
+          </a:prstGeom>
+          <a:noFill/>
+          <a:ln w="9525">
+            <a:noFill/>
+            <a:headEnd/>
+            <a:tailEnd/>
+          </a:ln>
+        </p:spPr>
+      </p:pic>
+    </p:spTree>
+  </p:cSld>
+</p:sld>
+</file>
+
+<file path=ppt/slides/slide9.xml><?xml version="1.0" encoding="utf-8"?>
+<p:sld xmlns:a="http://schemas.openxmlformats.org/drawingml/2006/main" xmlns:r="http://schemas.openxmlformats.org/officeDocument/2006/relationships" xmlns:p="http://schemas.openxmlformats.org/presentationml/2006/main">
+  <p:cSld>
+    <p:spTree>
+      <p:nvGrpSpPr>
+        <p:cNvPr id="1" name=""/>
+        <p:cNvGrpSpPr/>
+        <p:nvPr/>
+      </p:nvGrpSpPr>
+      <p:grpSpPr>
+        <a:xfrm>
+          <a:off x="0" y="0"/>
+          <a:ext cx="0" cy="0"/>
+          <a:chOff x="0" y="0"/>
+          <a:chExt cx="0" cy="0"/>
+        </a:xfrm>
+      </p:grpSpPr>
+      <p:sp>
+        <p:nvSpPr>
+          <p:cNvPr id="3" name="Content Placeholder 2"/>
+          <p:cNvSpPr>
+            <a:spLocks noGrp="1"/>
+          </p:cNvSpPr>
+          <p:nvPr>
+            <p:ph idx="1"/>
+          </p:nvPr>
+        </p:nvSpPr>
+        <p:spPr/>
+        <p:txBody>
+          <a:bodyPr/>
+          <a:lstStyle/>
+          <a:p>
+            <a:pPr lvl="0" indent="0" marL="0">
+              <a:buNone/>
+            </a:pPr>
+            <a:r>
+              <a:rPr/>
+              <a:t>Each layer answers a diagnosed problem: </a:t>
+            </a:r>
+            <a:r>
+              <a:rPr b="1"/>
+              <a:t>learning</a:t>
+            </a:r>
+            <a:r>
+              <a:rPr/>
+              <a:t> (gender-responsive pedagogy — Evans &amp; Yuan, 73+ RCTs), </a:t>
+            </a:r>
+            <a:r>
+              <a:rPr b="1"/>
+              <a:t>empowerment</a:t>
+            </a:r>
+            <a:r>
+              <a:rPr/>
+              <a:t> (ELA-style clubs — the retention answer, incl. early pregnancy; Bandiera 2018, φ-adjusted), and </a:t>
+            </a:r>
+            <a:r>
+              <a:rPr b="1"/>
+              <a:t>home environment</a:t>
+            </a:r>
+            <a:r>
+              <a:rPr/>
+              <a:t> (parenting — Cluver 2017 effect, Janowski 2025 delivery). Combined attendance effect ≈ +6.6 pp → +0.28 school-years → ~USD 970 PV per girl; </a:t>
+            </a:r>
+            <a:r>
+              <a:rPr b="1"/>
+              <a:t>BCR ≈ 4.1–6.1</a:t>
+            </a:r>
+            <a:r>
+              <a:rPr/>
+              <a:t> (central ~5.1), a conservative floor since learning gains (+0.06 SD) are not monetised. At full priority scale (~568,000 girls): ~USD 551M lifetime earnings for ~USD 107M invested.</a:t>
+            </a:r>
+          </a:p>
+        </p:txBody>
+      </p:sp>
     </p:spTree>
   </p:cSld>
 </p:sld>

</xml_diff>

<commit_message>
Census-anchored cost charts, relabelled b1, slides rendered
</commit_message>
<xml_diff>
--- a/reports/nepal_slides_short.pptx
+++ b/reports/nepal_slides_short.pptx
@@ -13,8 +13,6 @@
     <p:sldId id="261" r:id="rId7"/>
     <p:sldId id="262" r:id="rId8"/>
     <p:sldId id="263" r:id="rId9"/>
-    <p:sldId id="264" r:id="rId10"/>
-    <p:sldId id="265" r:id="rId11"/>
   </p:sldIdLst>
   <p:sldSz cx="9144000" cy="5143500" type="screen16x9"/>
   <p:notesSz cx="6858000" cy="9144000"/>
@@ -3152,8 +3150,6 @@
             <a:pPr lvl="0" indent="0" marL="0">
               <a:buNone/>
             </a:pPr>
-            <a:br/>
-            <a:br/>
             <a:r>
               <a:rPr/>
               <a:t>UNICEF</a:t>
@@ -3181,33 +3177,11 @@
             </a:pPr>
             <a:r>
               <a:rPr/>
-              <a:t>2026-05-01</a:t>
-            </a:r>
-          </a:p>
-        </p:txBody>
-      </p:sp>
-    </p:spTree>
-  </p:cSld>
-</p:sld>
-</file>
-
-<file path=ppt/slides/slide10.xml><?xml version="1.0" encoding="utf-8"?>
-<p:sld xmlns:a="http://schemas.openxmlformats.org/drawingml/2006/main" xmlns:r="http://schemas.openxmlformats.org/officeDocument/2006/relationships" xmlns:p="http://schemas.openxmlformats.org/presentationml/2006/main">
-  <p:cSld>
-    <p:spTree>
-      <p:nvGrpSpPr>
-        <p:cNvPr id="1" name=""/>
-        <p:cNvGrpSpPr/>
-        <p:nvPr/>
-      </p:nvGrpSpPr>
-      <p:grpSpPr>
-        <a:xfrm>
-          <a:off x="0" y="0"/>
-          <a:ext cx="0" cy="0"/>
-          <a:chOff x="0" y="0"/>
-          <a:chExt cx="0" cy="0"/>
-        </a:xfrm>
-      </p:grpSpPr>
+              <a:t>2026-10-01</a:t>
+            </a:r>
+          </a:p>
+        </p:txBody>
+      </p:sp>
     </p:spTree>
   </p:cSld>
 </p:sld>
@@ -3404,14 +3378,14 @@
             </a:pPr>
             <a:r>
               <a:rPr/>
-              <a:t>The Cost: NPR 8 Billion per Cohort</a:t>
+              <a:t>The Cost: NPR 16 Billion per Cohort</a:t>
             </a:r>
           </a:p>
         </p:txBody>
       </p:sp>
       <p:pic>
         <p:nvPicPr>
-          <p:cNvPr descr="../outputs/figures/c3_coi_vs_budget.png" id="0" name="Picture 1"/>
+          <p:cNvPr descr="../outputs/figures/c3_coi_vs_budget_census.png" id="0" name="Picture 1"/>
           <p:cNvPicPr>
             <a:picLocks noGrp="1" noChangeAspect="1"/>
           </p:cNvPicPr>
@@ -3425,8 +3399,8 @@
         </p:blipFill>
         <p:spPr bwMode="auto">
           <a:xfrm>
-            <a:off x="457200" y="1917700"/>
-            <a:ext cx="4038600" cy="1955800"/>
+            <a:off x="457200" y="1968500"/>
+            <a:ext cx="4038600" cy="1841500"/>
           </a:xfrm>
           <a:prstGeom prst="rect">
             <a:avLst/>
@@ -3481,7 +3455,7 @@
             </a:pPr>
             <a:r>
               <a:rPr/>
-              <a:t>The Recommendation: Four Priority Areas</a:t>
+              <a:t>The Recommendation: Four Priority Areas, Employment First</a:t>
             </a:r>
           </a:p>
         </p:txBody>
@@ -3587,77 +3561,6 @@
       </p:grpSpPr>
       <p:sp>
         <p:nvSpPr>
-          <p:cNvPr id="3" name="Content Placeholder 2"/>
-          <p:cNvSpPr>
-            <a:spLocks noGrp="1"/>
-          </p:cNvSpPr>
-          <p:nvPr>
-            <p:ph idx="1"/>
-          </p:nvPr>
-        </p:nvSpPr>
-        <p:spPr/>
-        <p:txBody>
-          <a:bodyPr/>
-          <a:lstStyle/>
-          <a:p>
-            <a:pPr lvl="0" indent="0" marL="0">
-              <a:buNone/>
-            </a:pPr>
-            <a:r>
-              <a:rPr/>
-              <a:t>In Bolivia (Aula Conectada investment case) girls are </a:t>
-            </a:r>
-            <a:r>
-              <a:rPr b="1"/>
-              <a:t>already in school</a:t>
-            </a:r>
-            <a:r>
-              <a:rPr/>
-              <a:t> (~92% enrolment ages 10–19, no gender gap in access); the binding constraints are </a:t>
-            </a:r>
-            <a:r>
-              <a:rPr b="1"/>
-              <a:t>learning quality, retention past 15, and the home environment</a:t>
-            </a:r>
-            <a:r>
-              <a:rPr/>
-              <a:t>. Violent discipline is concentrated in rural (52% vs 32% urban) and indigenous (46% vs 35%) homes and is associated with ~2 fewer years of schooling; </a:t>
-            </a:r>
-            <a:r>
-              <a:rPr b="1"/>
-              <a:t>early pregnancy</a:t>
-            </a:r>
-            <a:r>
-              <a:rPr/>
-              <a:t> is the strongest schooling correlate (−2.9 years). Contrast with Nepal: Nepal’s gap is the school-to-work transition; Bolivia’s is learning and retention — the same diagnostic lens, a different policy answer. Source: EDSA 2023 (INE Bolivia), survey-weighted.</a:t>
-            </a:r>
-          </a:p>
-        </p:txBody>
-      </p:sp>
-    </p:spTree>
-  </p:cSld>
-</p:sld>
-</file>
-
-<file path=ppt/slides/slide8.xml><?xml version="1.0" encoding="utf-8"?>
-<p:sld xmlns:a="http://schemas.openxmlformats.org/drawingml/2006/main" xmlns:r="http://schemas.openxmlformats.org/officeDocument/2006/relationships" xmlns:p="http://schemas.openxmlformats.org/presentationml/2006/main">
-  <p:cSld>
-    <p:spTree>
-      <p:nvGrpSpPr>
-        <p:cNvPr id="1" name=""/>
-        <p:cNvGrpSpPr/>
-        <p:nvPr/>
-      </p:nvGrpSpPr>
-      <p:grpSpPr>
-        <a:xfrm>
-          <a:off x="0" y="0"/>
-          <a:ext cx="0" cy="0"/>
-          <a:chOff x="0" y="0"/>
-          <a:chExt cx="0" cy="0"/>
-        </a:xfrm>
-      </p:grpSpPr>
-      <p:sp>
-        <p:nvSpPr>
           <p:cNvPr id="2" name="Title 1"/>
           <p:cNvSpPr>
             <a:spLocks noGrp="1"/>
@@ -3716,7 +3619,7 @@
 </p:sld>
 </file>
 
-<file path=ppt/slides/slide9.xml><?xml version="1.0" encoding="utf-8"?>
+<file path=ppt/slides/slide8.xml><?xml version="1.0" encoding="utf-8"?>
 <p:sld xmlns:a="http://schemas.openxmlformats.org/drawingml/2006/main" xmlns:r="http://schemas.openxmlformats.org/officeDocument/2006/relationships" xmlns:p="http://schemas.openxmlformats.org/presentationml/2006/main">
   <p:cSld>
     <p:spTree>
@@ -3733,63 +3636,6 @@
           <a:chExt cx="0" cy="0"/>
         </a:xfrm>
       </p:grpSpPr>
-      <p:sp>
-        <p:nvSpPr>
-          <p:cNvPr id="3" name="Content Placeholder 2"/>
-          <p:cNvSpPr>
-            <a:spLocks noGrp="1"/>
-          </p:cNvSpPr>
-          <p:nvPr>
-            <p:ph idx="1"/>
-          </p:nvPr>
-        </p:nvSpPr>
-        <p:spPr/>
-        <p:txBody>
-          <a:bodyPr/>
-          <a:lstStyle/>
-          <a:p>
-            <a:pPr lvl="0" indent="0" marL="0">
-              <a:buNone/>
-            </a:pPr>
-            <a:r>
-              <a:rPr/>
-              <a:t>Each layer answers a diagnosed problem: </a:t>
-            </a:r>
-            <a:r>
-              <a:rPr b="1"/>
-              <a:t>learning</a:t>
-            </a:r>
-            <a:r>
-              <a:rPr/>
-              <a:t> (gender-responsive pedagogy — Evans &amp; Yuan, 73+ RCTs), </a:t>
-            </a:r>
-            <a:r>
-              <a:rPr b="1"/>
-              <a:t>empowerment</a:t>
-            </a:r>
-            <a:r>
-              <a:rPr/>
-              <a:t> (ELA-style clubs — the retention answer, incl. early pregnancy; Bandiera 2018, φ-adjusted), and </a:t>
-            </a:r>
-            <a:r>
-              <a:rPr b="1"/>
-              <a:t>home environment</a:t>
-            </a:r>
-            <a:r>
-              <a:rPr/>
-              <a:t> (parenting — Cluver 2017 effect, Janowski 2025 delivery). Combined attendance effect ≈ +6.6 pp → +0.28 school-years → ~USD 970 PV per girl; </a:t>
-            </a:r>
-            <a:r>
-              <a:rPr b="1"/>
-              <a:t>BCR ≈ 4.1–6.1</a:t>
-            </a:r>
-            <a:r>
-              <a:rPr/>
-              <a:t> (central ~5.1), a conservative floor since learning gains (+0.06 SD) are not monetised. At full priority scale (~568,000 girls): ~USD 551M lifetime earnings for ~USD 107M invested.</a:t>
-            </a:r>
-          </a:p>
-        </p:txBody>
-      </p:sp>
     </p:spTree>
   </p:cSld>
 </p:sld>

</xml_diff>

<commit_message>
Slide versions of figures without plot titles (slide headers carry the title)
</commit_message>
<xml_diff>
--- a/reports/nepal_slides_short.pptx
+++ b/reports/nepal_slides_short.pptx
@@ -3231,7 +3231,7 @@
       </p:sp>
       <p:pic>
         <p:nvPicPr>
-          <p:cNvPr descr="../outputs/figures/d1_overall_gap.png" id="0" name="Picture 1"/>
+          <p:cNvPr descr="../outputs/figures/slides/d1_overall_gap.png" id="0" name="Picture 1"/>
           <p:cNvPicPr>
             <a:picLocks noGrp="1" noChangeAspect="1"/>
           </p:cNvPicPr>
@@ -3308,7 +3308,7 @@
       </p:sp>
       <p:pic>
         <p:nvPicPr>
-          <p:cNvPr descr="../outputs/figures/m1_mincer_lifetime.png" id="0" name="Picture 1"/>
+          <p:cNvPr descr="../outputs/figures/slides/m1_mincer_lifetime.png" id="0" name="Picture 1"/>
           <p:cNvPicPr>
             <a:picLocks noGrp="1" noChangeAspect="1"/>
           </p:cNvPicPr>
@@ -3385,7 +3385,7 @@
       </p:sp>
       <p:pic>
         <p:nvPicPr>
-          <p:cNvPr descr="../outputs/figures/c3_coi_vs_budget_census.png" id="0" name="Picture 1"/>
+          <p:cNvPr descr="../outputs/figures/slides/c3_coi_vs_budget_census.png" id="0" name="Picture 1"/>
           <p:cNvPicPr>
             <a:picLocks noGrp="1" noChangeAspect="1"/>
           </p:cNvPicPr>

</xml_diff>